<commit_message>
final changes before midsem ppt
</commit_message>
<xml_diff>
--- a/reports/mid_semester_presentation.pptx
+++ b/reports/mid_semester_presentation.pptx
@@ -4615,7 +4615,7 @@
                         </a:defRPr>
                       </a:pPr>
                       <a:r>
-                        <a:t>14.31</a:t>
+                        <a:t>14.30</a:t>
                       </a:r>
                     </a:p>
                   </a:txBody>
@@ -4635,7 +4635,7 @@
                         </a:defRPr>
                       </a:pPr>
                       <a:r>
-                        <a:t>309</a:t>
+                        <a:t>307</a:t>
                       </a:r>
                     </a:p>
                   </a:txBody>
@@ -6296,7 +6296,7 @@
               </a:defRPr>
             </a:pPr>
             <a:r>
-              <a:t>• Test MAE: 13.00, RMSE: 17.71, NASA: 411</a:t>
+              <a:t>• Test MAE: 10.97, RMSE: 14.90, NASA: 395</a:t>
             </a:r>
           </a:p>
           <a:p>
@@ -6914,7 +6914,7 @@
                         </a:defRPr>
                       </a:pPr>
                       <a:r>
-                        <a:t>12.70</a:t>
+                        <a:t>11.42</a:t>
                       </a:r>
                     </a:p>
                   </a:txBody>
@@ -6938,7 +6938,7 @@
                         </a:defRPr>
                       </a:pPr>
                       <a:r>
-                        <a:t>16.96</a:t>
+                        <a:t>15.06</a:t>
                       </a:r>
                     </a:p>
                   </a:txBody>
@@ -6962,7 +6962,7 @@
                         </a:defRPr>
                       </a:pPr>
                       <a:r>
-                        <a:t>373</a:t>
+                        <a:t>402</a:t>
                       </a:r>
                     </a:p>
                   </a:txBody>
@@ -7008,7 +7008,7 @@
                         </a:defRPr>
                       </a:pPr>
                       <a:r>
-                        <a:t>12.87</a:t>
+                        <a:t>11.45</a:t>
                       </a:r>
                     </a:p>
                   </a:txBody>
@@ -7028,7 +7028,7 @@
                         </a:defRPr>
                       </a:pPr>
                       <a:r>
-                        <a:t>16.53</a:t>
+                        <a:t>14.82</a:t>
                       </a:r>
                     </a:p>
                   </a:txBody>
@@ -7048,7 +7048,7 @@
                         </a:defRPr>
                       </a:pPr>
                       <a:r>
-                        <a:t>366</a:t>
+                        <a:t>372</a:t>
                       </a:r>
                     </a:p>
                   </a:txBody>
@@ -7094,7 +7094,7 @@
                         </a:defRPr>
                       </a:pPr>
                       <a:r>
-                        <a:t>24.82</a:t>
+                        <a:t>11.80</a:t>
                       </a:r>
                     </a:p>
                   </a:txBody>
@@ -7118,7 +7118,7 @@
                         </a:defRPr>
                       </a:pPr>
                       <a:r>
-                        <a:t>29.01</a:t>
+                        <a:t>16.07</a:t>
                       </a:r>
                     </a:p>
                   </a:txBody>
@@ -7142,7 +7142,7 @@
                         </a:defRPr>
                       </a:pPr>
                       <a:r>
-                        <a:t>1718</a:t>
+                        <a:t>520</a:t>
                       </a:r>
                     </a:p>
                   </a:txBody>
@@ -7188,7 +7188,7 @@
                         </a:defRPr>
                       </a:pPr>
                       <a:r>
-                        <a:t>24.76</a:t>
+                        <a:t>11.94</a:t>
                       </a:r>
                     </a:p>
                   </a:txBody>
@@ -7208,7 +7208,7 @@
                         </a:defRPr>
                       </a:pPr>
                       <a:r>
-                        <a:t>31.02</a:t>
+                        <a:t>16.21</a:t>
                       </a:r>
                     </a:p>
                   </a:txBody>
@@ -7228,7 +7228,7 @@
                         </a:defRPr>
                       </a:pPr>
                       <a:r>
-                        <a:t>2085</a:t>
+                        <a:t>548</a:t>
                       </a:r>
                     </a:p>
                   </a:txBody>
@@ -7938,7 +7938,7 @@
               </a:defRPr>
             </a:pPr>
             <a:r>
-              <a:t>• Test MAE: 11.12, RMSE: 14.94, NASA: 350</a:t>
+              <a:t>• Test MAE: 10.87, RMSE: 15.18, NASA: 357</a:t>
             </a:r>
           </a:p>
         </p:txBody>
@@ -8614,7 +8614,7 @@
               </a:defRPr>
             </a:pPr>
             <a:r>
-              <a:t>• Uncertainty-Error Correlation: 0.372</a:t>
+              <a:t>• Uncertainty-Error Correlation: 0.397</a:t>
             </a:r>
           </a:p>
           <a:p>
@@ -8646,7 +8646,7 @@
               </a:defRPr>
             </a:pPr>
             <a:r>
-              <a:t>• Mean uncertainty (std): 9.96 cycles</a:t>
+              <a:t>• Mean uncertainty (std): 8.52 cycles</a:t>
             </a:r>
           </a:p>
           <a:p>
@@ -9146,7 +9146,7 @@
                         </a:defRPr>
                       </a:pPr>
                       <a:r>
-                        <a:t>14.31</a:t>
+                        <a:t>14.30</a:t>
                       </a:r>
                     </a:p>
                   </a:txBody>
@@ -9170,7 +9170,7 @@
                         </a:defRPr>
                       </a:pPr>
                       <a:r>
-                        <a:t>309</a:t>
+                        <a:t>307</a:t>
                       </a:r>
                     </a:p>
                   </a:txBody>
@@ -9396,7 +9396,7 @@
                         </a:defRPr>
                       </a:pPr>
                       <a:r>
-                        <a:t>13.00</a:t>
+                        <a:t>10.97</a:t>
                       </a:r>
                     </a:p>
                   </a:txBody>
@@ -9416,7 +9416,7 @@
                         </a:defRPr>
                       </a:pPr>
                       <a:r>
-                        <a:t>17.71</a:t>
+                        <a:t>14.90</a:t>
                       </a:r>
                     </a:p>
                   </a:txBody>
@@ -9436,7 +9436,7 @@
                         </a:defRPr>
                       </a:pPr>
                       <a:r>
-                        <a:t>411</a:t>
+                        <a:t>395</a:t>
                       </a:r>
                     </a:p>
                   </a:txBody>
@@ -9482,7 +9482,7 @@
                         </a:defRPr>
                       </a:pPr>
                       <a:r>
-                        <a:t>12.70</a:t>
+                        <a:t>11.42</a:t>
                       </a:r>
                     </a:p>
                   </a:txBody>
@@ -9506,7 +9506,7 @@
                         </a:defRPr>
                       </a:pPr>
                       <a:r>
-                        <a:t>16.96</a:t>
+                        <a:t>15.06</a:t>
                       </a:r>
                     </a:p>
                   </a:txBody>
@@ -9530,7 +9530,7 @@
                         </a:defRPr>
                       </a:pPr>
                       <a:r>
-                        <a:t>373</a:t>
+                        <a:t>402</a:t>
                       </a:r>
                     </a:p>
                   </a:txBody>
@@ -9576,7 +9576,7 @@
                         </a:defRPr>
                       </a:pPr>
                       <a:r>
-                        <a:t>11.12</a:t>
+                        <a:t>10.87</a:t>
                       </a:r>
                     </a:p>
                   </a:txBody>
@@ -9596,7 +9596,7 @@
                         </a:defRPr>
                       </a:pPr>
                       <a:r>
-                        <a:t>14.94</a:t>
+                        <a:t>15.18</a:t>
                       </a:r>
                     </a:p>
                   </a:txBody>
@@ -9616,7 +9616,7 @@
                         </a:defRPr>
                       </a:pPr>
                       <a:r>
-                        <a:t>350</a:t>
+                        <a:t>357</a:t>
                       </a:r>
                     </a:p>
                   </a:txBody>
@@ -10460,7 +10460,7 @@
                         </a:defRPr>
                       </a:pPr>
                       <a:r>
-                        <a:t>11.12</a:t>
+                        <a:t>10.87</a:t>
                       </a:r>
                     </a:p>
                   </a:txBody>
@@ -10484,7 +10484,7 @@
                         </a:defRPr>
                       </a:pPr>
                       <a:r>
-                        <a:t>GB (Δ=0.73)</a:t>
+                        <a:t>GB (Δ=0.49)</a:t>
                       </a:r>
                     </a:p>
                   </a:txBody>
@@ -10530,7 +10530,7 @@
                         </a:defRPr>
                       </a:pPr>
                       <a:r>
-                        <a:t>14.31</a:t>
+                        <a:t>14.30</a:t>
                       </a:r>
                     </a:p>
                   </a:txBody>
@@ -10550,7 +10550,7 @@
                         </a:defRPr>
                       </a:pPr>
                       <a:r>
-                        <a:t>14.94</a:t>
+                        <a:t>15.18</a:t>
                       </a:r>
                     </a:p>
                   </a:txBody>
@@ -10616,7 +10616,7 @@
                         </a:defRPr>
                       </a:pPr>
                       <a:r>
-                        <a:t>309</a:t>
+                        <a:t>307</a:t>
                       </a:r>
                     </a:p>
                   </a:txBody>
@@ -10640,7 +10640,7 @@
                         </a:defRPr>
                       </a:pPr>
                       <a:r>
-                        <a:t>350</a:t>
+                        <a:t>357</a:t>
                       </a:r>
                     </a:p>
                   </a:txBody>
@@ -10730,7 +10730,7 @@
                         </a:defRPr>
                       </a:pPr>
                       <a:r>
-                        <a:t>9.96 cycles</a:t>
+                        <a:t>8.52 cycles</a:t>
                       </a:r>
                     </a:p>
                   </a:txBody>
@@ -11152,7 +11152,7 @@
               </a:defRPr>
             </a:pPr>
             <a:r>
-              <a:t>GB MAE=10.38 vs CT MAE=11.12 (Δ=0.73). GB NASA=309 vs CT NASA=350. CT provides uncertainty, explainability, and abstention that GB cannot.</a:t>
+              <a:t>GB MAE=10.38 vs CT MAE=10.87 (Δ=0.49). GB NASA=307 vs CT NASA=357. CT provides uncertainty, explainability, and abstention that GB cannot.</a:t>
             </a:r>
           </a:p>
         </p:txBody>
@@ -11463,7 +11463,7 @@
               </a:defRPr>
             </a:pPr>
             <a:r>
-              <a:t>Uncertainty-error correlation: 0.372 — the model IS more uncertain when wrong.</a:t>
+              <a:t>Uncertainty-error correlation: 0.397 — the model IS more uncertain when wrong.</a:t>
             </a:r>
           </a:p>
         </p:txBody>
@@ -11607,7 +11607,7 @@
               </a:defRPr>
             </a:pPr>
             <a:r>
-              <a:t>The CNN-Transformer's MAE (11.12) is close to GB (10.38).</a:t>
+              <a:t>The CNN-Transformer's MAE (10.87) is close to GB (10.38).</a:t>
             </a:r>
           </a:p>
           <a:p>
@@ -15484,7 +15484,7 @@
               </a:defRPr>
             </a:pPr>
             <a:r>
-              <a:t>✓ LSTM sequence model: MAE=13.00</a:t>
+              <a:t>✓ LSTM sequence model: MAE=10.97</a:t>
             </a:r>
           </a:p>
           <a:p>
@@ -15500,7 +15500,7 @@
               </a:defRPr>
             </a:pPr>
             <a:r>
-              <a:t>✓ CNN-Transformer with MC Dropout: MAE=11.12 with uncertainty</a:t>
+              <a:t>✓ CNN-Transformer with MC Dropout: MAE=10.87 with uncertainty</a:t>
             </a:r>
           </a:p>
           <a:p>
@@ -15516,7 +15516,7 @@
               </a:defRPr>
             </a:pPr>
             <a:r>
-              <a:t>✓ Uncertainty-error correlation: 0.372 (model knows when unsure)</a:t>
+              <a:t>✓ Uncertainty-error correlation: 0.397 (model knows when unsure)</a:t>
             </a:r>
           </a:p>
           <a:p>

</xml_diff>